<commit_message>
Actualizacion de inconsistncias en documentos de media importancia
</commit_message>
<xml_diff>
--- a/Fase 1/Evidencias Grupales/Presentacion_Proyecto.pptx
+++ b/Fase 1/Evidencias Grupales/Presentacion_Proyecto.pptx
@@ -5167,7 +5167,7 @@
                 <a:ea typeface="Calibri" pitchFamily="34" charset="-122"/>
                 <a:cs typeface="Calibri" pitchFamily="34" charset="-120"/>
               </a:rPr>
-              <a:t>www.easyoffice.cl</a:t>
+              <a:t>Fuente: easyoffice.cl</a:t>
             </a:r>
             <a:endParaRPr lang="es-MX" sz="1200" noProof="0" dirty="0"/>
           </a:p>
@@ -9468,7 +9468,7 @@
                 <a:ea typeface="Calibri" pitchFamily="34" charset="-122"/>
                 <a:cs typeface="Calibri" pitchFamily="34" charset="-120"/>
               </a:rPr>
-              <a:t>Líder de proyecto</a:t>
+              <a:t>Product Owner</a:t>
             </a:r>
             <a:endParaRPr lang="es-MX" sz="1250" noProof="0" dirty="0"/>
           </a:p>
@@ -9698,7 +9698,7 @@
                 <a:ea typeface="Calibri" pitchFamily="34" charset="-122"/>
                 <a:cs typeface="Calibri" pitchFamily="34" charset="-120"/>
               </a:rPr>
-              <a:t>Levantamiento documental</a:t>
+              <a:t>Scrum Master</a:t>
             </a:r>
             <a:endParaRPr lang="es-MX" sz="1250" noProof="0" dirty="0"/>
           </a:p>
@@ -9878,7 +9878,7 @@
                 <a:ea typeface="Calibri" pitchFamily="34" charset="-122"/>
                 <a:cs typeface="Calibri" pitchFamily="34" charset="-120"/>
               </a:rPr>
-              <a:t>QA – Desarrollo </a:t>
+              <a:t>Developer (QA) – </a:t>
             </a:r>
             <a:r>
               <a:rPr lang="es-MX" sz="1250" b="1" noProof="0" dirty="0" err="1">

</xml_diff>